<commit_message>
Update repo handle to peacestate (URL refs + regenerated deck)
Point username references and the deck's closing slide at
github.com/peacestate/lifepilot; regenerate deck PDF + PPTX.
</commit_message>
<xml_diff>
--- a/docs/lifepilot-deck.pptx
+++ b/docs/lifepilot-deck.pptx
@@ -3099,7 +3099,7 @@
       <p:grpSpPr/>
       <p:pic>
         <p:nvPicPr>
-          <p:cNvPr id="2" name="Picture 1" descr="slide_01.png"/>
+          <p:cNvPr id="2" name="Picture 1" descr="s_00.png"/>
           <p:cNvPicPr>
             <a:picLocks noChangeAspect="1"/>
           </p:cNvPicPr>
@@ -3141,7 +3141,7 @@
       <p:grpSpPr/>
       <p:pic>
         <p:nvPicPr>
-          <p:cNvPr id="2" name="Picture 1" descr="slide_10.png"/>
+          <p:cNvPr id="2" name="Picture 1" descr="s_09.png"/>
           <p:cNvPicPr>
             <a:picLocks noChangeAspect="1"/>
           </p:cNvPicPr>
@@ -3183,7 +3183,7 @@
       <p:grpSpPr/>
       <p:pic>
         <p:nvPicPr>
-          <p:cNvPr id="2" name="Picture 1" descr="slide_02.png"/>
+          <p:cNvPr id="2" name="Picture 1" descr="s_01.png"/>
           <p:cNvPicPr>
             <a:picLocks noChangeAspect="1"/>
           </p:cNvPicPr>
@@ -3225,7 +3225,7 @@
       <p:grpSpPr/>
       <p:pic>
         <p:nvPicPr>
-          <p:cNvPr id="2" name="Picture 1" descr="slide_03.png"/>
+          <p:cNvPr id="2" name="Picture 1" descr="s_02.png"/>
           <p:cNvPicPr>
             <a:picLocks noChangeAspect="1"/>
           </p:cNvPicPr>
@@ -3267,7 +3267,7 @@
       <p:grpSpPr/>
       <p:pic>
         <p:nvPicPr>
-          <p:cNvPr id="2" name="Picture 1" descr="slide_04.png"/>
+          <p:cNvPr id="2" name="Picture 1" descr="s_03.png"/>
           <p:cNvPicPr>
             <a:picLocks noChangeAspect="1"/>
           </p:cNvPicPr>
@@ -3309,7 +3309,7 @@
       <p:grpSpPr/>
       <p:pic>
         <p:nvPicPr>
-          <p:cNvPr id="2" name="Picture 1" descr="slide_05.png"/>
+          <p:cNvPr id="2" name="Picture 1" descr="s_04.png"/>
           <p:cNvPicPr>
             <a:picLocks noChangeAspect="1"/>
           </p:cNvPicPr>
@@ -3351,7 +3351,7 @@
       <p:grpSpPr/>
       <p:pic>
         <p:nvPicPr>
-          <p:cNvPr id="2" name="Picture 1" descr="slide_06.png"/>
+          <p:cNvPr id="2" name="Picture 1" descr="s_05.png"/>
           <p:cNvPicPr>
             <a:picLocks noChangeAspect="1"/>
           </p:cNvPicPr>
@@ -3393,7 +3393,7 @@
       <p:grpSpPr/>
       <p:pic>
         <p:nvPicPr>
-          <p:cNvPr id="2" name="Picture 1" descr="slide_07.png"/>
+          <p:cNvPr id="2" name="Picture 1" descr="s_06.png"/>
           <p:cNvPicPr>
             <a:picLocks noChangeAspect="1"/>
           </p:cNvPicPr>
@@ -3435,7 +3435,7 @@
       <p:grpSpPr/>
       <p:pic>
         <p:nvPicPr>
-          <p:cNvPr id="2" name="Picture 1" descr="slide_08.png"/>
+          <p:cNvPr id="2" name="Picture 1" descr="s_07.png"/>
           <p:cNvPicPr>
             <a:picLocks noChangeAspect="1"/>
           </p:cNvPicPr>
@@ -3477,7 +3477,7 @@
       <p:grpSpPr/>
       <p:pic>
         <p:nvPicPr>
-          <p:cNvPr id="2" name="Picture 1" descr="slide_09.png"/>
+          <p:cNvPr id="2" name="Picture 1" descr="s_08.png"/>
           <p:cNvPicPr>
             <a:picLocks noChangeAspect="1"/>
           </p:cNvPicPr>

</xml_diff>